<commit_message>
Update rank #9 → #12 (leaderboard revised by organizers)
- README: Rank #9 → #12
- Deck slides 1, 13, 14, 15: all #9 references updated to #12
- '30-place improvement' corrected to '27-place improvement' (39→12)
- 'top-9 entries' corrected to 'top-12' on slide 14
- Rebuilt pxr_challenge_presentation_v4.pptx with updated figures
</commit_message>
<xml_diff>
--- a/pxr_challenge_presentation_v4.pptx
+++ b/pxr_challenge_presentation_v4.pptx
@@ -506,7 +506,7 @@
                   </c:pt>
                   <c:pt idx="1">
                     <c:v>Moderate
-(4–5.5)</c:v>
+(4-5.5)</c:v>
                   </c:pt>
                   <c:pt idx="2">
                     <c:v>Potent
@@ -592,7 +592,7 @@
                   </c:pt>
                   <c:pt idx="1">
                     <c:v>Moderate
-(4–5.5)</c:v>
+(4-5.5)</c:v>
                   </c:pt>
                   <c:pt idx="2">
                     <c:v>Potent
@@ -1551,7 +1551,7 @@
 (n=27)</c:v>
                   </c:pt>
                   <c:pt idx="1">
-                    <c:v>Moderate 4–5.5
+                    <c:v>Moderate 4-5.5
 (n=172)</c:v>
                   </c:pt>
                   <c:pt idx="2">
@@ -1637,7 +1637,7 @@
 (n=27)</c:v>
                   </c:pt>
                   <c:pt idx="1">
-                    <c:v>Moderate 4–5.5
+                    <c:v>Moderate 4-5.5
 (n=172)</c:v>
                   </c:pt>
                   <c:pt idx="2">
@@ -1916,7 +1916,7 @@
                   </c:pt>
                   <c:pt idx="1">
                     <c:v>Moderate
-(4–5.5)</c:v>
+(4-5.5)</c:v>
                   </c:pt>
                   <c:pt idx="2">
                     <c:v>Potent
@@ -2009,7 +2009,7 @@
                   </c:pt>
                   <c:pt idx="1">
                     <c:v>Moderate
-(4–5.5)</c:v>
+(4-5.5)</c:v>
                   </c:pt>
                   <c:pt idx="2">
                     <c:v>Potent
@@ -2616,7 +2616,7 @@
                 <c:ptCount val="2"/>
                 <c:lvl>
                   <c:pt idx="0">
-                    <c:v>Gashaw  (#9)</c:v>
+                    <c:v>Gashaw  (#12)</c:v>
                   </c:pt>
                   <c:pt idx="1">
                     <c:v>matcha-croissant  (#1)</c:v>
@@ -3185,7 +3185,7 @@
           <a:p>
             <a:r>
               <a:rPr lang="en-US" dirty="0"/>
-              <a:t>Title: PXR pEC50 prediction, OpenADMET blind challenge. Final rank #9/100+ qualifying teams (Phase 2 leaderboard). Phase 1 rank 39. 3-model ensemble, all open-source.</a:t>
+              <a:t>Title: PXR pEC50 prediction, OpenADMET blind challenge. Final rank #12/100+ qualifying teams (Phase 2 leaderboard). Phase 1 rank 39. 3-model ensemble, all open-source.</a:t>
             </a:r>
             <a:endParaRPr lang="en-US" dirty="0"/>
           </a:p>
@@ -3273,7 +3273,7 @@
           <a:p>
             <a:r>
               <a:rPr lang="en-US" dirty="0"/>
-              <a:t>Three models: pp50 (general regression, 75%), p13d (inactive discrimination, 15%), UniMol (3D geometry, 10%). Pearson r pp50-UniMol=0.919 confirms genuine complementarity.</a:t>
+              <a:t>Three models: pp50 (general regression, 75%), p13d (inactive discrimination, 15%), UniMol (3D geometry, 10%).</a:t>
             </a:r>
             <a:endParaRPr lang="en-US" dirty="0"/>
           </a:p>
@@ -3537,7 +3537,7 @@
           <a:p>
             <a:r>
               <a:rPr lang="en-US" dirty="0"/>
-              <a:t>Final submission: LB rank #9/100+, RAE 0.5841, MAE 0.4213, Spearman 0.8028. Holdout-30 proxy was 0.4471. Clear improvement progression from Phase 1 through aug2 stages.</a:t>
+              <a:t>Final submission: LB rank #12/100+, RAE 0.5841, MAE 0.4213, Spearman 0.8028. Holdout-30 proxy was 0.4471.</a:t>
             </a:r>
             <a:endParaRPr lang="en-US" dirty="0"/>
           </a:p>
@@ -3625,7 +3625,7 @@
           <a:p>
             <a:r>
               <a:rPr lang="en-US" dirty="0"/>
-              <a:t>Bootstrap head-to-head: Gashaw MAE 0.4213±0.0296 vs matcha-croissant 0.4061±0.0280. p=0.402, not significant even without HB correction. Delta MAE only 0.015, smaller than 1 SD.</a:t>
+              <a:t>Bootstrap head-to-head: Gashaw MAE 0.4213±0.0296 vs matcha-croissant 0.4061±0.0280. p=0.402, not significant. Delta MAE only 0.015, smaller than 1 SD.</a:t>
             </a:r>
             <a:endParaRPr lang="en-US" dirty="0"/>
           </a:p>
@@ -4951,7 +4951,7 @@
                 <a:ea typeface="Trebuchet MS" pitchFamily="34" charset="-122"/>
                 <a:cs typeface="Trebuchet MS" pitchFamily="34" charset="-120"/>
               </a:rPr>
-              <a:t>#9</a:t>
+              <a:t>#12</a:t>
             </a:r>
             <a:endParaRPr lang="en-US" sz="2000" dirty="0"/>
           </a:p>
@@ -5173,7 +5173,7 @@
                 <a:ea typeface="Calibri" pitchFamily="34" charset="-122"/>
                 <a:cs typeface="Calibri" pitchFamily="34" charset="-120"/>
               </a:rPr>
-              <a:t>30-place improvement</a:t>
+              <a:t>27-place improvement</a:t>
             </a:r>
             <a:endParaRPr lang="en-US" sz="800" dirty="0"/>
           </a:p>
@@ -7106,7 +7106,7 @@
                 <a:ea typeface="Calibri" pitchFamily="34" charset="-122"/>
                 <a:cs typeface="Calibri" pitchFamily="34" charset="-120"/>
               </a:rPr>
-              <a:t>3D molecular geometry provides signal orthogonal to 2D graph. Most beneficial for the 65% moderate-activity compounds (pEC50 4–5.5) in the blinded test set.</a:t>
+              <a:t>3D molecular geometry provides signal orthogonal to 2D graph. Most beneficial for the 65% moderate-activity compounds (pEC50 4-5.5) in the blinded test set.</a:t>
             </a:r>
             <a:endParaRPr lang="en-US" sz="900" dirty="0"/>
           </a:p>
@@ -8614,7 +8614,7 @@
                 <a:ea typeface="Trebuchet MS" pitchFamily="34" charset="-122"/>
                 <a:cs typeface="Trebuchet MS" pitchFamily="34" charset="-120"/>
               </a:rPr>
-              <a:t>Moderate  (4–5.5, n=201 in P1)</a:t>
+              <a:t>Moderate  (4-5.5, n=201 in P1)</a:t>
             </a:r>
             <a:endParaRPr lang="en-US" sz="1100" dirty="0"/>
           </a:p>
@@ -9122,7 +9122,7 @@
                 <a:ea typeface="Trebuchet MS" pitchFamily="34" charset="-122"/>
                 <a:cs typeface="Trebuchet MS" pitchFamily="34" charset="-120"/>
               </a:rPr>
-              <a:t>Phase 2 Leaderboard — Rank #9 / 100+ Teams</a:t>
+              <a:t>Phase 2 Leaderboard — Rank #12 / 100+ Teams</a:t>
             </a:r>
             <a:endParaRPr lang="en-US" sz="2100" dirty="0"/>
           </a:p>
@@ -9195,7 +9195,7 @@
                 <a:ea typeface="Trebuchet MS" pitchFamily="34" charset="-122"/>
                 <a:cs typeface="Trebuchet MS" pitchFamily="34" charset="-120"/>
               </a:rPr>
-              <a:t>#9</a:t>
+              <a:t>#12</a:t>
             </a:r>
             <a:endParaRPr lang="en-US" sz="2000" dirty="0"/>
           </a:p>
@@ -10193,7 +10193,7 @@
                 <a:ea typeface="Calibri" pitchFamily="34" charset="-122"/>
                 <a:cs typeface="Calibri" pitchFamily="34" charset="-120"/>
               </a:rPr>
-              <a:t>#9 / 100+ qualifying teams</a:t>
+              <a:t>#12 / 100+ qualifying teams</a:t>
             </a:r>
             <a:endParaRPr lang="en-US" sz="900" dirty="0"/>
           </a:p>
@@ -11227,7 +11227,7 @@
                 <a:ea typeface="Calibri" pitchFamily="34" charset="-122"/>
                 <a:cs typeface="Calibri" pitchFamily="34" charset="-120"/>
               </a:rPr>
-              <a:t>260 Set 2 compounds with MAE SD ~0.029. All top-9 entries fall within one bootstrap SD of each other — statistically a single cluster.</a:t>
+              <a:t>260 Set 2 compounds with MAE SD ~0.029. All top-12 entries fall within one bootstrap SD of each other — statistically a single cluster.</a:t>
             </a:r>
             <a:endParaRPr lang="en-US" sz="950" dirty="0"/>
           </a:p>
@@ -11664,7 +11664,7 @@
                 <a:ea typeface="Calibri" pitchFamily="34" charset="-122"/>
                 <a:cs typeface="Calibri" pitchFamily="34" charset="-120"/>
               </a:rPr>
-              <a:t>Phase 2 final rank #9 / 100+ qualifying teams · LB MAE 0.4213 · Spearman 0.8028</a:t>
+              <a:t>Phase 2 final rank #12 / 100+ qualifying teams · LB MAE 0.4213 · Spearman 0.8028</a:t>
             </a:r>
             <a:endParaRPr lang="en-US" sz="950" dirty="0"/>
           </a:p>
@@ -11717,7 +11717,7 @@
                 <a:ea typeface="Calibri" pitchFamily="34" charset="-122"/>
                 <a:cs typeface="Calibri" pitchFamily="34" charset="-120"/>
               </a:rPr>
-              <a:t>Phase 1 rank #39 → Phase 2 rank #9 — 30-place improvement, open-source tools only</a:t>
+              <a:t>Phase 1 rank #39 → Phase 2 rank #12 — 27-place improvement, open-source tools only</a:t>
             </a:r>
             <a:endParaRPr lang="en-US" sz="950" dirty="0"/>
           </a:p>
@@ -15076,7 +15076,7 @@
                 <a:ea typeface="Trebuchet MS" pitchFamily="34" charset="-122"/>
                 <a:cs typeface="Trebuchet MS" pitchFamily="34" charset="-120"/>
               </a:rPr>
-              <a:t>MAE: 0.4622  (↓11.4%)</a:t>
+              <a:t>MAE: 0.4622  (↑0 11.4%)</a:t>
             </a:r>
             <a:endParaRPr lang="en-US" sz="1100" dirty="0"/>
           </a:p>
@@ -15115,7 +15115,7 @@
                 <a:ea typeface="Trebuchet MS" pitchFamily="34" charset="-122"/>
                 <a:cs typeface="Trebuchet MS" pitchFamily="34" charset="-120"/>
               </a:rPr>
-              <a:t>Spearman: 0.8137  (↑12%)</a:t>
+              <a:t>Spearman: 0.8137  (↑ 12%)</a:t>
             </a:r>
             <a:endParaRPr lang="en-US" sz="1100" dirty="0"/>
           </a:p>

</xml_diff>

<commit_message>
Reframe narrative: Tier 1 standing over rank number
- README: Rank #12 → Tier 1 (activity track, 43-entry top tier)
- Slide 1: 'Final Rank #12' card → 'Tier 1 / OpenADMET Standing'; '#39 improvement' → '#39 → T1 journey'
- Slide 13: Header → 'Phase 2 — OpenADMET Tier 1 · Activity Track'; top metric card → 'Tier 1 / 43-entry top tier'; table row → 'Tier 1, Activity Track (of 43)'
- Slide 14: Header → 'Tier 1 Confirmed'; bar label → 'Gashaw (Tier 1)'; first insight card references official OpenADMET Tier 1 designation (43 entries, sequential significance testing)
- Slide 15: Achievements lead with Tier 1 status and '#39 → Tier 1' journey
- Rebuilt pxr_challenge_presentation_v4.pptx
</commit_message>
<xml_diff>
--- a/pxr_challenge_presentation_v4.pptx
+++ b/pxr_challenge_presentation_v4.pptx
@@ -2616,7 +2616,7 @@
                 <c:ptCount val="2"/>
                 <c:lvl>
                   <c:pt idx="0">
-                    <c:v>Gashaw  (#12)</c:v>
+                    <c:v>Gashaw  (Tier 1)</c:v>
                   </c:pt>
                   <c:pt idx="1">
                     <c:v>matcha-croissant  (#1)</c:v>
@@ -3185,7 +3185,7 @@
           <a:p>
             <a:r>
               <a:rPr lang="en-US" dirty="0"/>
-              <a:t>Title: PXR pEC50 prediction, OpenADMET blind challenge. Final rank #12/100+ qualifying teams (Phase 2 leaderboard). Phase 1 rank 39. 3-model ensemble, all open-source.</a:t>
+              <a:t>Title: PXR pEC50 prediction, OpenADMET blind challenge. Official Tier 1, activity track (43-entry top tier, statistically indistinguishable from rank #1). Phase 1 rank 39. 3-model ensemble, all open-source.</a:t>
             </a:r>
             <a:endParaRPr lang="en-US" dirty="0"/>
           </a:p>
@@ -3537,7 +3537,7 @@
           <a:p>
             <a:r>
               <a:rPr lang="en-US" dirty="0"/>
-              <a:t>Final submission: LB rank #12/100+, RAE 0.5841, MAE 0.4213, Spearman 0.8028. Holdout-30 proxy was 0.4471.</a:t>
+              <a:t>Final submission: OpenADMET Tier 1 (activity track), RAE 0.5841, MAE 0.4213, Spearman 0.8028. Holdout-30 proxy was 0.4471. 43 entries placed in Tier 1 — all statistically indistinguishable from rank #1.</a:t>
             </a:r>
             <a:endParaRPr lang="en-US" dirty="0"/>
           </a:p>
@@ -4951,7 +4951,7 @@
                 <a:ea typeface="Trebuchet MS" pitchFamily="34" charset="-122"/>
                 <a:cs typeface="Trebuchet MS" pitchFamily="34" charset="-120"/>
               </a:rPr>
-              <a:t>#12</a:t>
+              <a:t>Tier 1</a:t>
             </a:r>
             <a:endParaRPr lang="en-US" sz="2000" dirty="0"/>
           </a:p>
@@ -4990,7 +4990,7 @@
                 <a:ea typeface="Calibri" pitchFamily="34" charset="-122"/>
                 <a:cs typeface="Calibri" pitchFamily="34" charset="-120"/>
               </a:rPr>
-              <a:t>Final Rank</a:t>
+              <a:t>OpenADMET Standing</a:t>
             </a:r>
             <a:endParaRPr lang="en-US" sz="900" dirty="0"/>
           </a:p>
@@ -5029,7 +5029,7 @@
                 <a:ea typeface="Calibri" pitchFamily="34" charset="-122"/>
                 <a:cs typeface="Calibri" pitchFamily="34" charset="-120"/>
               </a:rPr>
-              <a:t>Phase 2 leaderboard</a:t>
+              <a:t>Activity track, top tier</a:t>
             </a:r>
             <a:endParaRPr lang="en-US" sz="800" dirty="0"/>
           </a:p>
@@ -5095,7 +5095,7 @@
                 <a:ea typeface="Trebuchet MS" pitchFamily="34" charset="-122"/>
                 <a:cs typeface="Trebuchet MS" pitchFamily="34" charset="-120"/>
               </a:rPr>
-              <a:t>#39</a:t>
+              <a:t>#39 → T1</a:t>
             </a:r>
             <a:endParaRPr lang="en-US" sz="2000" dirty="0"/>
           </a:p>
@@ -5134,7 +5134,7 @@
                 <a:ea typeface="Calibri" pitchFamily="34" charset="-122"/>
                 <a:cs typeface="Calibri" pitchFamily="34" charset="-120"/>
               </a:rPr>
-              <a:t>Phase 1 Rank</a:t>
+              <a:t>Phase 1 → Phase 2</a:t>
             </a:r>
             <a:endParaRPr lang="en-US" sz="900" dirty="0"/>
           </a:p>
@@ -5173,7 +5173,7 @@
                 <a:ea typeface="Calibri" pitchFamily="34" charset="-122"/>
                 <a:cs typeface="Calibri" pitchFamily="34" charset="-120"/>
               </a:rPr>
-              <a:t>27-place improvement</a:t>
+              <a:t>27-rank improvement</a:t>
             </a:r>
             <a:endParaRPr lang="en-US" sz="800" dirty="0"/>
           </a:p>
@@ -9122,7 +9122,7 @@
                 <a:ea typeface="Trebuchet MS" pitchFamily="34" charset="-122"/>
                 <a:cs typeface="Trebuchet MS" pitchFamily="34" charset="-120"/>
               </a:rPr>
-              <a:t>Phase 2 Leaderboard — Rank #12 / 100+ Teams</a:t>
+              <a:t>Phase 2 — OpenADMET Tier 1 · Activity Track</a:t>
             </a:r>
             <a:endParaRPr lang="en-US" sz="2100" dirty="0"/>
           </a:p>
@@ -9195,7 +9195,7 @@
                 <a:ea typeface="Trebuchet MS" pitchFamily="34" charset="-122"/>
                 <a:cs typeface="Trebuchet MS" pitchFamily="34" charset="-120"/>
               </a:rPr>
-              <a:t>#12</a:t>
+              <a:t>Tier 1</a:t>
             </a:r>
             <a:endParaRPr lang="en-US" sz="2000" dirty="0"/>
           </a:p>
@@ -9234,7 +9234,7 @@
                 <a:ea typeface="Calibri" pitchFamily="34" charset="-122"/>
                 <a:cs typeface="Calibri" pitchFamily="34" charset="-120"/>
               </a:rPr>
-              <a:t>Final LB Rank</a:t>
+              <a:t>OpenADMET Standing</a:t>
             </a:r>
             <a:endParaRPr lang="en-US" sz="850" dirty="0"/>
           </a:p>
@@ -9273,7 +9273,7 @@
                 <a:ea typeface="Calibri" pitchFamily="34" charset="-122"/>
                 <a:cs typeface="Calibri" pitchFamily="34" charset="-120"/>
               </a:rPr>
-              <a:t>of 100+ qualifying teams</a:t>
+              <a:t>43-entry top tier</a:t>
             </a:r>
             <a:endParaRPr lang="en-US" sz="800" dirty="0"/>
           </a:p>
@@ -10154,7 +10154,7 @@
                 <a:ea typeface="Calibri" pitchFamily="34" charset="-122"/>
                 <a:cs typeface="Calibri" pitchFamily="34" charset="-120"/>
               </a:rPr>
-              <a:t>LB Rank</a:t>
+              <a:t>LB Standing</a:t>
             </a:r>
             <a:endParaRPr lang="en-US" sz="900" dirty="0"/>
           </a:p>
@@ -10193,7 +10193,7 @@
                 <a:ea typeface="Calibri" pitchFamily="34" charset="-122"/>
                 <a:cs typeface="Calibri" pitchFamily="34" charset="-120"/>
               </a:rPr>
-              <a:t>#12 / 100+ qualifying teams</a:t>
+              <a:t>Tier 1, Activity Track (of 43)</a:t>
             </a:r>
             <a:endParaRPr lang="en-US" sz="900" dirty="0"/>
           </a:p>
@@ -10637,7 +10637,7 @@
                 <a:ea typeface="Trebuchet MS" pitchFamily="34" charset="-122"/>
                 <a:cs typeface="Trebuchet MS" pitchFamily="34" charset="-120"/>
               </a:rPr>
-              <a:t>Open-Source vs. Rank #1 — No Significant Gap</a:t>
+              <a:t>Open-Source vs. Rank #1 — Tier 1 Confirmed</a:t>
             </a:r>
             <a:endParaRPr lang="en-US" sz="2100" dirty="0"/>
           </a:p>
@@ -11188,7 +11188,7 @@
                 <a:ea typeface="Trebuchet MS" pitchFamily="34" charset="-122"/>
                 <a:cs typeface="Trebuchet MS" pitchFamily="34" charset="-120"/>
               </a:rPr>
-              <a:t>Test set too small to separate close competitors</a:t>
+              <a:t>Official OpenADMET Tier 1 designation</a:t>
             </a:r>
             <a:endParaRPr lang="en-US" sz="1050" dirty="0"/>
           </a:p>
@@ -11227,7 +11227,7 @@
                 <a:ea typeface="Calibri" pitchFamily="34" charset="-122"/>
                 <a:cs typeface="Calibri" pitchFamily="34" charset="-120"/>
               </a:rPr>
-              <a:t>260 Set 2 compounds with MAE SD ~0.029. All top-12 entries fall within one bootstrap SD of each other — statistically a single cluster.</a:t>
+              <a:t>OpenADMET's sequential significance testing placed 43 activity-track entries in Tier 1 — all statistically indistinguishable from rank #1. This submission is one of them.</a:t>
             </a:r>
             <a:endParaRPr lang="en-US" sz="950" dirty="0"/>
           </a:p>
@@ -11664,7 +11664,7 @@
                 <a:ea typeface="Calibri" pitchFamily="34" charset="-122"/>
                 <a:cs typeface="Calibri" pitchFamily="34" charset="-120"/>
               </a:rPr>
-              <a:t>Phase 2 final rank #12 / 100+ qualifying teams · LB MAE 0.4213 · Spearman 0.8028</a:t>
+              <a:t>OpenADMET Tier 1, activity track — statistically indistinguishable from rank #1 · MAE 0.4213 · Spearman 0.8028</a:t>
             </a:r>
             <a:endParaRPr lang="en-US" sz="950" dirty="0"/>
           </a:p>
@@ -11717,7 +11717,7 @@
                 <a:ea typeface="Calibri" pitchFamily="34" charset="-122"/>
                 <a:cs typeface="Calibri" pitchFamily="34" charset="-120"/>
               </a:rPr>
-              <a:t>Phase 1 rank #39 → Phase 2 rank #12 — 27-place improvement, open-source tools only</a:t>
+              <a:t>Phase 1 rank #39 → Phase 2 Tier 1 — 27-rank improvement with open-source tools only</a:t>
             </a:r>
             <a:endParaRPr lang="en-US" sz="950" dirty="0"/>
           </a:p>

</xml_diff>

<commit_message>
Correct error analysis: 60% → 53%, bias +0.97 → +0.99, chart bars updated
- Slide 7 text: 'drove 60% of total RAE' → '53%' (measured on unblinded Set 1)
- Slide 7 chart: % of RAE bars [60,28,12] → [53,33,14] (all three corrected)
- Slide 7 bias: '+0.97 pEC50 units' → '+0.99 pEC50 units'
- README: three occurrences of 60% → 53%, bias +0.97 → +0.99
- Source: prediction_vs_actual_analysis.html, ensemble N=253, exact values 52.8/33.1/14.1%
</commit_message>
<xml_diff>
--- a/pxr_challenge_presentation_v4.pptx
+++ b/pxr_challenge_presentation_v4.pptx
@@ -609,13 +609,13 @@
                 <c:formatCode>General</c:formatCode>
                 <c:ptCount val="3"/>
                 <c:pt idx="0">
-                  <c:v>60</c:v>
+                  <c:v>53</c:v>
                 </c:pt>
                 <c:pt idx="1">
-                  <c:v>28</c:v>
+                  <c:v>33</c:v>
                 </c:pt>
                 <c:pt idx="2">
-                  <c:v>12</c:v>
+                  <c:v>14</c:v>
                 </c:pt>
               </c:numCache>
             </c:numRef>
@@ -4241,7 +4241,7 @@
           <a:p>
             <a:r>
               <a:rPr lang="en-US" dirty="0"/>
-              <a:t>Diagnosis: 22% of compounds (inactives) drove 60% of RAE. Two fixes: asymmetric BCE architecture and data augmentation with confirmed inactives and high-potency hits.</a:t>
+              <a:t>Diagnosis: 22% of compounds (inactives) drove 53% of RAE (measured on unblinded Set 1). Two fixes: asymmetric BCE architecture and data augmentation with confirmed inactives and high-potency hits.</a:t>
             </a:r>
             <a:endParaRPr lang="en-US" dirty="0"/>
           </a:p>
@@ -19209,7 +19209,7 @@
                 <a:ea typeface="Trebuchet MS" pitchFamily="34" charset="-122"/>
                 <a:cs typeface="Trebuchet MS" pitchFamily="34" charset="-120"/>
               </a:rPr>
-              <a:t>drove  60%  of total RAE</a:t>
+              <a:t>drove  53%  of total RAE</a:t>
             </a:r>
             <a:endParaRPr lang="en-US" sz="1500" dirty="0"/>
           </a:p>
@@ -19248,7 +19248,7 @@
                 <a:ea typeface="Calibri" pitchFamily="34" charset="-122"/>
                 <a:cs typeface="Calibri" pitchFamily="34" charset="-120"/>
               </a:rPr>
-              <a:t>Average over-prediction: +0.97 pEC50 units</a:t>
+              <a:t>Average over-prediction: +0.99 pEC50 units</a:t>
             </a:r>
             <a:endParaRPr lang="en-US" sz="1050" dirty="0"/>
           </a:p>

</xml_diff>

<commit_message>
Add Kendall τ 0.6221 to slides & HTML; add leaderboard banner to analysis page; fix percentile range P5-P100
</commit_message>
<xml_diff>
--- a/pxr_challenge_presentation_v4.pptx
+++ b/pxr_challenge_presentation_v4.pptx
@@ -3537,7 +3537,7 @@
           <a:p>
             <a:r>
               <a:rPr lang="en-US" dirty="0"/>
-              <a:t>Final submission: OpenADMET Tier 1 (activity track), RAE 0.5841, MAE 0.4213, Spearman 0.8028. Holdout-30 proxy was 0.4471. 43 entries placed in Tier 1 — all statistically indistinguishable from rank #1.</a:t>
+              <a:t>Final submission: OpenADMET Tier 1 (activity track). MAE 0.4213 · RAE 0.5841 · R² 0.5528 · Spearman 0.8028 · Kendall τ 0.6221. Holdout-30 proxy was 0.4471. 43 entries placed in Tier 1 — all statistically indistinguishable from rank #1.</a:t>
             </a:r>
             <a:endParaRPr lang="en-US" dirty="0"/>
           </a:p>
@@ -9796,7 +9796,7 @@
         <p:spPr>
           <a:xfrm>
             <a:off x="5486400" y="1901952"/>
-            <a:ext cx="3337560" cy="448056"/>
+            <a:ext cx="3337560" cy="402336"/>
           </a:xfrm>
           <a:prstGeom prst="rect">
             <a:avLst/>
@@ -9821,7 +9821,7 @@
         <p:spPr>
           <a:xfrm>
             <a:off x="5577840" y="1901952"/>
-            <a:ext cx="804672" cy="448056"/>
+            <a:ext cx="804672" cy="402336"/>
           </a:xfrm>
           <a:prstGeom prst="rect">
             <a:avLst/>
@@ -9860,7 +9860,7 @@
         <p:spPr>
           <a:xfrm>
             <a:off x="6419088" y="1901952"/>
-            <a:ext cx="2331720" cy="448056"/>
+            <a:ext cx="2331720" cy="402336"/>
           </a:xfrm>
           <a:prstGeom prst="rect">
             <a:avLst/>
@@ -9898,8 +9898,8 @@
         </p:nvSpPr>
         <p:spPr>
           <a:xfrm>
-            <a:off x="5486400" y="2386584"/>
-            <a:ext cx="3337560" cy="448056"/>
+            <a:off x="5486400" y="2340864"/>
+            <a:ext cx="3337560" cy="402336"/>
           </a:xfrm>
           <a:prstGeom prst="rect">
             <a:avLst/>
@@ -9923,8 +9923,8 @@
         </p:nvSpPr>
         <p:spPr>
           <a:xfrm>
-            <a:off x="5577840" y="2386584"/>
-            <a:ext cx="804672" cy="448056"/>
+            <a:off x="5577840" y="2340864"/>
+            <a:ext cx="804672" cy="402336"/>
           </a:xfrm>
           <a:prstGeom prst="rect">
             <a:avLst/>
@@ -9962,8 +9962,8 @@
         </p:nvSpPr>
         <p:spPr>
           <a:xfrm>
-            <a:off x="6419088" y="2386584"/>
-            <a:ext cx="2331720" cy="448056"/>
+            <a:off x="6419088" y="2340864"/>
+            <a:ext cx="2331720" cy="402336"/>
           </a:xfrm>
           <a:prstGeom prst="rect">
             <a:avLst/>
@@ -10001,8 +10001,8 @@
         </p:nvSpPr>
         <p:spPr>
           <a:xfrm>
-            <a:off x="5486400" y="2871216"/>
-            <a:ext cx="3337560" cy="448056"/>
+            <a:off x="5486400" y="2779776"/>
+            <a:ext cx="3337560" cy="402336"/>
           </a:xfrm>
           <a:prstGeom prst="rect">
             <a:avLst/>
@@ -10026,8 +10026,8 @@
         </p:nvSpPr>
         <p:spPr>
           <a:xfrm>
-            <a:off x="5577840" y="2871216"/>
-            <a:ext cx="804672" cy="448056"/>
+            <a:off x="5577840" y="2779776"/>
+            <a:ext cx="804672" cy="402336"/>
           </a:xfrm>
           <a:prstGeom prst="rect">
             <a:avLst/>
@@ -10065,8 +10065,8 @@
         </p:nvSpPr>
         <p:spPr>
           <a:xfrm>
-            <a:off x="6419088" y="2871216"/>
-            <a:ext cx="2331720" cy="448056"/>
+            <a:off x="6419088" y="2779776"/>
+            <a:ext cx="2331720" cy="402336"/>
           </a:xfrm>
           <a:prstGeom prst="rect">
             <a:avLst/>
@@ -10104,8 +10104,8 @@
         </p:nvSpPr>
         <p:spPr>
           <a:xfrm>
-            <a:off x="5486400" y="3355848"/>
-            <a:ext cx="3337560" cy="448056"/>
+            <a:off x="5486400" y="3218688"/>
+            <a:ext cx="3337560" cy="402336"/>
           </a:xfrm>
           <a:prstGeom prst="rect">
             <a:avLst/>
@@ -10129,8 +10129,8 @@
         </p:nvSpPr>
         <p:spPr>
           <a:xfrm>
-            <a:off x="5577840" y="3355848"/>
-            <a:ext cx="804672" cy="448056"/>
+            <a:off x="5577840" y="3218688"/>
+            <a:ext cx="804672" cy="402336"/>
           </a:xfrm>
           <a:prstGeom prst="rect">
             <a:avLst/>
@@ -10168,8 +10168,8 @@
         </p:nvSpPr>
         <p:spPr>
           <a:xfrm>
-            <a:off x="6419088" y="3355848"/>
-            <a:ext cx="2331720" cy="448056"/>
+            <a:off x="6419088" y="3218688"/>
+            <a:ext cx="2331720" cy="402336"/>
           </a:xfrm>
           <a:prstGeom prst="rect">
             <a:avLst/>
@@ -10207,8 +10207,8 @@
         </p:nvSpPr>
         <p:spPr>
           <a:xfrm>
-            <a:off x="5486400" y="3840480"/>
-            <a:ext cx="3337560" cy="448056"/>
+            <a:off x="5486400" y="3657600"/>
+            <a:ext cx="3337560" cy="402336"/>
           </a:xfrm>
           <a:prstGeom prst="rect">
             <a:avLst/>
@@ -10232,8 +10232,8 @@
         </p:nvSpPr>
         <p:spPr>
           <a:xfrm>
-            <a:off x="5577840" y="3840480"/>
-            <a:ext cx="804672" cy="448056"/>
+            <a:off x="5577840" y="3657600"/>
+            <a:ext cx="804672" cy="402336"/>
           </a:xfrm>
           <a:prstGeom prst="rect">
             <a:avLst/>
@@ -10257,7 +10257,7 @@
                 <a:ea typeface="Calibri" pitchFamily="34" charset="-122"/>
                 <a:cs typeface="Calibri" pitchFamily="34" charset="-120"/>
               </a:rPr>
-              <a:t>LB RAE</a:t>
+              <a:t>LB MAE  ·  RAE</a:t>
             </a:r>
             <a:endParaRPr lang="en-US" sz="900" dirty="0"/>
           </a:p>
@@ -10271,8 +10271,8 @@
         </p:nvSpPr>
         <p:spPr>
           <a:xfrm>
-            <a:off x="6419088" y="3840480"/>
-            <a:ext cx="2331720" cy="448056"/>
+            <a:off x="6419088" y="3657600"/>
+            <a:ext cx="2331720" cy="402336"/>
           </a:xfrm>
           <a:prstGeom prst="rect">
             <a:avLst/>
@@ -10296,7 +10296,7 @@
                 <a:ea typeface="Calibri" pitchFamily="34" charset="-122"/>
                 <a:cs typeface="Calibri" pitchFamily="34" charset="-120"/>
               </a:rPr>
-              <a:t>0.5841  ·  LB MAE 0.4213</a:t>
+              <a:t>0.4213  ·  0.5841</a:t>
             </a:r>
             <a:endParaRPr lang="en-US" sz="900" dirty="0"/>
           </a:p>
@@ -10310,8 +10310,8 @@
         </p:nvSpPr>
         <p:spPr>
           <a:xfrm>
-            <a:off x="5486400" y="4325112"/>
-            <a:ext cx="3337560" cy="448056"/>
+            <a:off x="5486400" y="4096512"/>
+            <a:ext cx="3337560" cy="402336"/>
           </a:xfrm>
           <a:prstGeom prst="rect">
             <a:avLst/>
@@ -10335,8 +10335,8 @@
         </p:nvSpPr>
         <p:spPr>
           <a:xfrm>
-            <a:off x="5577840" y="4325112"/>
-            <a:ext cx="804672" cy="448056"/>
+            <a:off x="5577840" y="4096512"/>
+            <a:ext cx="804672" cy="402336"/>
           </a:xfrm>
           <a:prstGeom prst="rect">
             <a:avLst/>
@@ -10360,7 +10360,7 @@
                 <a:ea typeface="Calibri" pitchFamily="34" charset="-122"/>
                 <a:cs typeface="Calibri" pitchFamily="34" charset="-120"/>
               </a:rPr>
-              <a:t>LB Spearman</a:t>
+              <a:t>LB R²</a:t>
             </a:r>
             <a:endParaRPr lang="en-US" sz="900" dirty="0"/>
           </a:p>
@@ -10374,8 +10374,8 @@
         </p:nvSpPr>
         <p:spPr>
           <a:xfrm>
-            <a:off x="6419088" y="4325112"/>
-            <a:ext cx="2331720" cy="448056"/>
+            <a:off x="6419088" y="4096512"/>
+            <a:ext cx="2331720" cy="402336"/>
           </a:xfrm>
           <a:prstGeom prst="rect">
             <a:avLst/>
@@ -10399,7 +10399,7 @@
                 <a:ea typeface="Calibri" pitchFamily="34" charset="-122"/>
                 <a:cs typeface="Calibri" pitchFamily="34" charset="-120"/>
               </a:rPr>
-              <a:t>0.8028  ·  LB R² 0.5528</a:t>
+              <a:t>0.5528</a:t>
             </a:r>
             <a:endParaRPr lang="en-US" sz="900" dirty="0"/>
           </a:p>
@@ -10413,8 +10413,8 @@
         </p:nvSpPr>
         <p:spPr>
           <a:xfrm>
-            <a:off x="5486400" y="4809744"/>
-            <a:ext cx="3337560" cy="448056"/>
+            <a:off x="5486400" y="4535424"/>
+            <a:ext cx="3337560" cy="402336"/>
           </a:xfrm>
           <a:prstGeom prst="rect">
             <a:avLst/>
@@ -10438,8 +10438,8 @@
         </p:nvSpPr>
         <p:spPr>
           <a:xfrm>
-            <a:off x="5577840" y="4809744"/>
-            <a:ext cx="804672" cy="448056"/>
+            <a:off x="5577840" y="4535424"/>
+            <a:ext cx="804672" cy="402336"/>
           </a:xfrm>
           <a:prstGeom prst="rect">
             <a:avLst/>
@@ -10463,6 +10463,109 @@
                 <a:ea typeface="Calibri" pitchFamily="34" charset="-122"/>
                 <a:cs typeface="Calibri" pitchFamily="34" charset="-120"/>
               </a:rPr>
+              <a:t>LB Spearman  ·  Kendall τ</a:t>
+            </a:r>
+            <a:endParaRPr lang="en-US" sz="900" dirty="0"/>
+          </a:p>
+        </p:txBody>
+      </p:sp>
+      <p:sp>
+        <p:nvSpPr>
+          <p:cNvPr id="43" name="Text 40"/>
+          <p:cNvSpPr/>
+          <p:nvPr/>
+        </p:nvSpPr>
+        <p:spPr>
+          <a:xfrm>
+            <a:off x="6419088" y="4535424"/>
+            <a:ext cx="2331720" cy="402336"/>
+          </a:xfrm>
+          <a:prstGeom prst="rect">
+            <a:avLst/>
+          </a:prstGeom>
+          <a:noFill/>
+          <a:ln/>
+        </p:spPr>
+        <p:txBody>
+          <a:bodyPr wrap="square" lIns="0" tIns="0" rIns="0" bIns="0" rtlCol="0" anchor="ctr"/>
+          <a:lstStyle/>
+          <a:p>
+            <a:pPr indent="0" marL="0">
+              <a:buNone/>
+            </a:pPr>
+            <a:r>
+              <a:rPr lang="en-US" sz="900" dirty="0">
+                <a:solidFill>
+                  <a:srgbClr val="1E3A4A"/>
+                </a:solidFill>
+                <a:latin typeface="Calibri" pitchFamily="34" charset="0"/>
+                <a:ea typeface="Calibri" pitchFamily="34" charset="-122"/>
+                <a:cs typeface="Calibri" pitchFamily="34" charset="-120"/>
+              </a:rPr>
+              <a:t>0.8028  ·  0.6221</a:t>
+            </a:r>
+            <a:endParaRPr lang="en-US" sz="900" dirty="0"/>
+          </a:p>
+        </p:txBody>
+      </p:sp>
+      <p:sp>
+        <p:nvSpPr>
+          <p:cNvPr id="44" name="Shape 41"/>
+          <p:cNvSpPr/>
+          <p:nvPr/>
+        </p:nvSpPr>
+        <p:spPr>
+          <a:xfrm>
+            <a:off x="5486400" y="4974336"/>
+            <a:ext cx="3337560" cy="402336"/>
+          </a:xfrm>
+          <a:prstGeom prst="rect">
+            <a:avLst/>
+          </a:prstGeom>
+          <a:solidFill>
+            <a:srgbClr val="EBF6FA"/>
+          </a:solidFill>
+          <a:ln w="6350">
+            <a:solidFill>
+              <a:srgbClr val="E2E8F0"/>
+            </a:solidFill>
+            <a:prstDash val="solid"/>
+          </a:ln>
+        </p:spPr>
+      </p:sp>
+      <p:sp>
+        <p:nvSpPr>
+          <p:cNvPr id="45" name="Text 42"/>
+          <p:cNvSpPr/>
+          <p:nvPr/>
+        </p:nvSpPr>
+        <p:spPr>
+          <a:xfrm>
+            <a:off x="5577840" y="4974336"/>
+            <a:ext cx="804672" cy="402336"/>
+          </a:xfrm>
+          <a:prstGeom prst="rect">
+            <a:avLst/>
+          </a:prstGeom>
+          <a:noFill/>
+          <a:ln/>
+        </p:spPr>
+        <p:txBody>
+          <a:bodyPr wrap="square" lIns="0" tIns="0" rIns="0" bIns="0" rtlCol="0" anchor="ctr"/>
+          <a:lstStyle/>
+          <a:p>
+            <a:pPr indent="0" marL="0">
+              <a:buNone/>
+            </a:pPr>
+            <a:r>
+              <a:rPr lang="en-US" sz="900" b="1" dirty="0">
+                <a:solidFill>
+                  <a:srgbClr val="64748B"/>
+                </a:solidFill>
+                <a:latin typeface="Calibri" pitchFamily="34" charset="0"/>
+                <a:ea typeface="Calibri" pitchFamily="34" charset="-122"/>
+                <a:cs typeface="Calibri" pitchFamily="34" charset="-120"/>
+              </a:rPr>
               <a:t>Holdout-30 RAE</a:t>
             </a:r>
             <a:endParaRPr lang="en-US" sz="900" dirty="0"/>
@@ -10471,14 +10574,14 @@
       </p:sp>
       <p:sp>
         <p:nvSpPr>
-          <p:cNvPr id="43" name="Text 40"/>
-          <p:cNvSpPr/>
-          <p:nvPr/>
-        </p:nvSpPr>
-        <p:spPr>
-          <a:xfrm>
-            <a:off x="6419088" y="4809744"/>
-            <a:ext cx="2331720" cy="448056"/>
+          <p:cNvPr id="46" name="Text 43"/>
+          <p:cNvSpPr/>
+          <p:nvPr/>
+        </p:nvSpPr>
+        <p:spPr>
+          <a:xfrm>
+            <a:off x="6419088" y="4974336"/>
+            <a:ext cx="2331720" cy="402336"/>
           </a:xfrm>
           <a:prstGeom prst="rect">
             <a:avLst/>

</xml_diff>